<commit_message>
Anchor report windows to exact calendar months; regenerate September 2026 deck
Co-Authored-By: Claude Sonnet 5.5 <noreply@anthropic.com>
Claude-Session: https://claude.ai/code/session_01Y2RYXXXWmANdfeSAyyzmUa
</commit_message>
<xml_diff>
--- a/Ocean Crest Pier Monthly Report — September 2026.pptx
+++ b/Ocean Crest Pier Monthly Report — September 2026.pptx
@@ -478,25 +478,25 @@
                 <c:formatCode>General</c:formatCode>
                 <c:ptCount val="30"/>
                 <c:pt idx="0">
-                  <c:v>740</c:v>
+                  <c:v>0</c:v>
                 </c:pt>
                 <c:pt idx="1">
                   <c:v>0</c:v>
                 </c:pt>
                 <c:pt idx="2">
-                  <c:v>745</c:v>
+                  <c:v>0</c:v>
                 </c:pt>
                 <c:pt idx="3">
-                  <c:v>1637</c:v>
+                  <c:v>504</c:v>
                 </c:pt>
                 <c:pt idx="4">
-                  <c:v>840</c:v>
+                  <c:v>178</c:v>
                 </c:pt>
                 <c:pt idx="5">
-                  <c:v>438</c:v>
+                  <c:v>0</c:v>
                 </c:pt>
                 <c:pt idx="6">
-                  <c:v>281</c:v>
+                  <c:v>378</c:v>
                 </c:pt>
                 <c:pt idx="7">
                   <c:v>0</c:v>
@@ -505,61 +505,61 @@
                   <c:v>0</c:v>
                 </c:pt>
                 <c:pt idx="9">
-                  <c:v>449</c:v>
+                  <c:v>56</c:v>
                 </c:pt>
                 <c:pt idx="10">
-                  <c:v>308</c:v>
+                  <c:v>151</c:v>
                 </c:pt>
                 <c:pt idx="11">
-                  <c:v>227</c:v>
+                  <c:v>51</c:v>
                 </c:pt>
                 <c:pt idx="12">
+                  <c:v>223</c:v>
+                </c:pt>
+                <c:pt idx="13">
+                  <c:v>360</c:v>
+                </c:pt>
+                <c:pt idx="14">
+                  <c:v>117</c:v>
+                </c:pt>
+                <c:pt idx="15">
+                  <c:v>76</c:v>
+                </c:pt>
+                <c:pt idx="16">
+                  <c:v>77</c:v>
+                </c:pt>
+                <c:pt idx="17">
+                  <c:v>270</c:v>
+                </c:pt>
+                <c:pt idx="18">
+                  <c:v>71</c:v>
+                </c:pt>
+                <c:pt idx="19">
+                  <c:v>236</c:v>
+                </c:pt>
+                <c:pt idx="20">
                   <c:v>0</c:v>
                 </c:pt>
-                <c:pt idx="13">
-                  <c:v>657</c:v>
-                </c:pt>
-                <c:pt idx="14">
+                <c:pt idx="21">
+                  <c:v>422</c:v>
+                </c:pt>
+                <c:pt idx="22">
                   <c:v>0</c:v>
                 </c:pt>
-                <c:pt idx="15">
+                <c:pt idx="23">
+                  <c:v>720</c:v>
+                </c:pt>
+                <c:pt idx="24">
                   <c:v>0</c:v>
                 </c:pt>
-                <c:pt idx="16">
-                  <c:v>504</c:v>
-                </c:pt>
-                <c:pt idx="17">
-                  <c:v>178</c:v>
-                </c:pt>
-                <c:pt idx="18">
-                  <c:v>378</c:v>
-                </c:pt>
-                <c:pt idx="19">
-                  <c:v>56</c:v>
-                </c:pt>
-                <c:pt idx="20">
-                  <c:v>202</c:v>
-                </c:pt>
-                <c:pt idx="21">
-                  <c:v>583</c:v>
-                </c:pt>
-                <c:pt idx="22">
-                  <c:v>193</c:v>
-                </c:pt>
-                <c:pt idx="23">
-                  <c:v>347</c:v>
-                </c:pt>
-                <c:pt idx="24">
-                  <c:v>307</c:v>
-                </c:pt>
                 <c:pt idx="25">
-                  <c:v>422</c:v>
+                  <c:v>550</c:v>
                 </c:pt>
                 <c:pt idx="26">
-                  <c:v>720</c:v>
+                  <c:v>0</c:v>
                 </c:pt>
                 <c:pt idx="27">
-                  <c:v>550</c:v>
+                  <c:v>0</c:v>
                 </c:pt>
                 <c:pt idx="28">
                   <c:v>0</c:v>
@@ -5404,7 +5404,7 @@
                 </a:solidFill>
                 <a:latin typeface="Jost"/>
               </a:rPr>
-              <a:t>Restore Instagram posting cadence — down 64% this period (17 vs. 47 posts). Aim for 47+ posts next period.</a:t>
+              <a:t>Restore Instagram posting cadence — down 37% this period (17 vs. 27 posts). Aim for 27+ posts next period.</a:t>
             </a:r>
           </a:p>
           <a:p>
@@ -5458,7 +5458,7 @@
                 </a:solidFill>
                 <a:latin typeface="Jost"/>
               </a:rPr>
-              <a:t>Close the engagement gap on Facebook — trailing TikTok by 7.4 points (0.00% vs. 7.40%). Borrow whatever content approach is working on TikTok.</a:t>
+              <a:t>Close the engagement gap on Facebook — trailing TikTok by 6.7 points (0.74% vs. 7.40%). Borrow whatever content approach is working on TikTok.</a:t>
             </a:r>
           </a:p>
         </p:txBody>
@@ -5665,11 +5665,11 @@
             <a:r>
               <a:rPr sz="900" b="1">
                 <a:solidFill>
-                  <a:srgbClr val="7A7889"/>
+                  <a:srgbClr val="2D55C9"/>
                 </a:solidFill>
                 <a:latin typeface="Jost"/>
               </a:rPr>
-              <a:t>↓ -42.8%</a:t>
+              <a:t>↑ +38.7%</a:t>
             </a:r>
           </a:p>
         </p:txBody>
@@ -5746,11 +5746,11 @@
             <a:r>
               <a:rPr sz="900" b="1">
                 <a:solidFill>
-                  <a:srgbClr val="7A7889"/>
+                  <a:srgbClr val="2D55C9"/>
                 </a:solidFill>
                 <a:latin typeface="Jost"/>
               </a:rPr>
-              <a:t>↓ -47.6%</a:t>
+              <a:t>↑ +24.2%</a:t>
             </a:r>
           </a:p>
         </p:txBody>
@@ -5831,7 +5831,7 @@
                 </a:solidFill>
                 <a:latin typeface="Jost"/>
               </a:rPr>
-              <a:t>↑ +49.0%</a:t>
+              <a:t>↑ +56.8%</a:t>
             </a:r>
           </a:p>
         </p:txBody>
@@ -6021,7 +6021,7 @@
                         </a:defRPr>
                       </a:pPr>
                       <a:r>
-                        <a:t>47</a:t>
+                        <a:t>27</a:t>
                       </a:r>
                     </a:p>
                   </a:txBody>
@@ -6045,7 +6045,7 @@
                         </a:defRPr>
                       </a:pPr>
                       <a:r>
-                        <a:t>↓ -63.8%</a:t>
+                        <a:t>↓ -37.0%</a:t>
                       </a:r>
                     </a:p>
                   </a:txBody>
@@ -6119,7 +6119,7 @@
                         </a:defRPr>
                       </a:pPr>
                       <a:r>
-                        <a:t>10.8K</a:t>
+                        <a:t>4.4K</a:t>
                       </a:r>
                     </a:p>
                   </a:txBody>
@@ -6137,13 +6137,13 @@
                       <a:pPr>
                         <a:defRPr sz="800">
                           <a:solidFill>
-                            <a:srgbClr val="7A7889"/>
-                          </a:solidFill>
-                          <a:latin typeface="Jost"/>
-                        </a:defRPr>
-                      </a:pPr>
-                      <a:r>
-                        <a:t>↓ -42.8%</a:t>
+                            <a:srgbClr val="2D55C9"/>
+                          </a:solidFill>
+                          <a:latin typeface="Jost"/>
+                        </a:defRPr>
+                      </a:pPr>
+                      <a:r>
+                        <a:t>↑ +38.7%</a:t>
                       </a:r>
                     </a:p>
                   </a:txBody>
@@ -6217,7 +6217,7 @@
                         </a:defRPr>
                       </a:pPr>
                       <a:r>
-                        <a:t>7.2K</a:t>
+                        <a:t>3.0K</a:t>
                       </a:r>
                     </a:p>
                   </a:txBody>
@@ -6235,13 +6235,13 @@
                       <a:pPr>
                         <a:defRPr sz="800">
                           <a:solidFill>
-                            <a:srgbClr val="7A7889"/>
-                          </a:solidFill>
-                          <a:latin typeface="Jost"/>
-                        </a:defRPr>
-                      </a:pPr>
-                      <a:r>
-                        <a:t>↓ -47.6%</a:t>
+                            <a:srgbClr val="2D55C9"/>
+                          </a:solidFill>
+                          <a:latin typeface="Jost"/>
+                        </a:defRPr>
+                      </a:pPr>
+                      <a:r>
+                        <a:t>↑ +24.2%</a:t>
                       </a:r>
                     </a:p>
                   </a:txBody>
@@ -6315,7 +6315,7 @@
                         </a:defRPr>
                       </a:pPr>
                       <a:r>
-                        <a:t>273</a:t>
+                        <a:t>109</a:t>
                       </a:r>
                     </a:p>
                   </a:txBody>
@@ -6333,13 +6333,13 @@
                       <a:pPr>
                         <a:defRPr sz="800">
                           <a:solidFill>
-                            <a:srgbClr val="7A7889"/>
-                          </a:solidFill>
-                          <a:latin typeface="Jost"/>
-                        </a:defRPr>
-                      </a:pPr>
-                      <a:r>
-                        <a:t>↓ -25.6%</a:t>
+                            <a:srgbClr val="2D55C9"/>
+                          </a:solidFill>
+                          <a:latin typeface="Jost"/>
+                        </a:defRPr>
+                      </a:pPr>
+                      <a:r>
+                        <a:t>↑ +86.2%</a:t>
                       </a:r>
                     </a:p>
                   </a:txBody>
@@ -6413,7 +6413,7 @@
                         </a:defRPr>
                       </a:pPr>
                       <a:r>
-                        <a:t>29</a:t>
+                        <a:t>10</a:t>
                       </a:r>
                     </a:p>
                   </a:txBody>
@@ -6431,13 +6431,13 @@
                       <a:pPr>
                         <a:defRPr sz="800">
                           <a:solidFill>
-                            <a:srgbClr val="7A7889"/>
-                          </a:solidFill>
-                          <a:latin typeface="Jost"/>
-                        </a:defRPr>
-                      </a:pPr>
-                      <a:r>
-                        <a:t>↓ -27.6%</a:t>
+                            <a:srgbClr val="2D55C9"/>
+                          </a:solidFill>
+                          <a:latin typeface="Jost"/>
+                        </a:defRPr>
+                      </a:pPr>
+                      <a:r>
+                        <a:t>↑ +110.0%</a:t>
                       </a:r>
                     </a:p>
                   </a:txBody>
@@ -6511,7 +6511,7 @@
                         </a:defRPr>
                       </a:pPr>
                       <a:r>
-                        <a:t>29</a:t>
+                        <a:t>13</a:t>
                       </a:r>
                     </a:p>
                   </a:txBody>
@@ -6529,13 +6529,13 @@
                       <a:pPr>
                         <a:defRPr sz="800">
                           <a:solidFill>
-                            <a:srgbClr val="7A7889"/>
-                          </a:solidFill>
-                          <a:latin typeface="Jost"/>
-                        </a:defRPr>
-                      </a:pPr>
-                      <a:r>
-                        <a:t>↓ -3.4%</a:t>
+                            <a:srgbClr val="2D55C9"/>
+                          </a:solidFill>
+                          <a:latin typeface="Jost"/>
+                        </a:defRPr>
+                      </a:pPr>
+                      <a:r>
+                        <a:t>↑ +115.4%</a:t>
                       </a:r>
                     </a:p>
                   </a:txBody>
@@ -6707,7 +6707,7 @@
                         </a:defRPr>
                       </a:pPr>
                       <a:r>
-                        <a:t>4.60%</a:t>
+                        <a:t>4.37%</a:t>
                       </a:r>
                     </a:p>
                   </a:txBody>
@@ -6731,7 +6731,7 @@
                         </a:defRPr>
                       </a:pPr>
                       <a:r>
-                        <a:t>↑ +49.0%</a:t>
+                        <a:t>↑ +56.8%</a:t>
                       </a:r>
                     </a:p>
                   </a:txBody>
@@ -6755,40 +6755,6 @@
         <p:spPr>
           <a:xfrm>
             <a:off x="512064" y="3310128"/>
-            <a:ext cx="8119872" cy="182880"/>
-          </a:xfrm>
-          <a:prstGeom prst="rect">
-            <a:avLst/>
-          </a:prstGeom>
-          <a:noFill/>
-        </p:spPr>
-        <p:txBody>
-          <a:bodyPr wrap="square">
-            <a:spAutoFit/>
-          </a:bodyPr>
-          <a:lstStyle/>
-          <a:p>
-            <a:r>
-              <a:rPr sz="1000" i="1">
-                <a:solidFill>
-                  <a:srgbClr val="7A7889"/>
-                </a:solidFill>
-                <a:latin typeface="Jost"/>
-              </a:rPr>
-              <a:t>Most metrics are down this period alongside a 64% drop in posting frequency (17 vs. 47 posts).</a:t>
-            </a:r>
-          </a:p>
-        </p:txBody>
-      </p:sp>
-      <p:sp>
-        <p:nvSpPr>
-          <p:cNvPr id="9" name="TextBox 8"/>
-          <p:cNvSpPr txBox="1"/>
-          <p:nvPr/>
-        </p:nvSpPr>
-        <p:spPr>
-          <a:xfrm>
-            <a:off x="512064" y="3520440"/>
             <a:ext cx="8119872" cy="219456"/>
           </a:xfrm>
           <a:prstGeom prst="rect">
@@ -6816,15 +6782,15 @@
       </p:sp>
       <p:graphicFrame>
         <p:nvGraphicFramePr>
-          <p:cNvPr id="10" name="Chart 9"/>
+          <p:cNvPr id="9" name="Chart 8"/>
           <p:cNvGraphicFramePr>
             <a:graphicFrameLocks noGrp="1"/>
           </p:cNvGraphicFramePr>
           <p:nvPr/>
         </p:nvGraphicFramePr>
         <p:xfrm>
-          <a:off x="512064" y="3739896"/>
-          <a:ext cx="8119872" cy="1152144"/>
+          <a:off x="512064" y="3529584"/>
+          <a:ext cx="8119872" cy="1362456"/>
         </p:xfrm>
         <a:graphic>
           <a:graphicData uri="http://schemas.openxmlformats.org/drawingml/2006/chart">
@@ -8127,7 +8093,7 @@
                 </a:solidFill>
                 <a:latin typeface="Jost"/>
               </a:rPr>
-              <a:t>0.00%</a:t>
+              <a:t>0.74%</a:t>
             </a:r>
           </a:p>
           <a:p>
@@ -8135,11 +8101,11 @@
             <a:r>
               <a:rPr sz="900" b="1">
                 <a:solidFill>
-                  <a:srgbClr val="3A3845"/>
+                  <a:srgbClr val="7A7889"/>
                 </a:solidFill>
                 <a:latin typeface="Jost"/>
               </a:rPr>
-              <a:t>flat (0/0)</a:t>
+              <a:t>↓ -42.1%</a:t>
             </a:r>
           </a:p>
         </p:txBody>
@@ -8950,7 +8916,7 @@
                         </a:defRPr>
                       </a:pPr>
                       <a:r>
-                        <a:t>Weighted Eng. Rate (reach)</a:t>
+                        <a:t>Weighted Eng. Rate (impressions)</a:t>
                       </a:r>
                     </a:p>
                   </a:txBody>
@@ -8974,7 +8940,7 @@
                         </a:defRPr>
                       </a:pPr>
                       <a:r>
-                        <a:t>0.00%</a:t>
+                        <a:t>0.74%</a:t>
                       </a:r>
                     </a:p>
                   </a:txBody>
@@ -8998,7 +8964,7 @@
                         </a:defRPr>
                       </a:pPr>
                       <a:r>
-                        <a:t>0.00%</a:t>
+                        <a:t>1.28%</a:t>
                       </a:r>
                     </a:p>
                   </a:txBody>
@@ -9016,13 +8982,13 @@
                       <a:pPr>
                         <a:defRPr sz="800">
                           <a:solidFill>
-                            <a:srgbClr val="3A3845"/>
-                          </a:solidFill>
-                          <a:latin typeface="Jost"/>
-                        </a:defRPr>
-                      </a:pPr>
-                      <a:r>
-                        <a:t>flat (0/0)</a:t>
+                            <a:srgbClr val="7A7889"/>
+                          </a:solidFill>
+                          <a:latin typeface="Jost"/>
+                        </a:defRPr>
+                      </a:pPr>
+                      <a:r>
+                        <a:t>↓ -42.1%</a:t>
                       </a:r>
                     </a:p>
                   </a:txBody>

</xml_diff>

<commit_message>
Fix top-posts slide: merge multi-photo posts, label Stories/uncaptioned posts, rank feed posts only
Co-Authored-By: Claude Sonnet 5.5 <noreply@anthropic.com>
Claude-Session: https://claude.ai/code/session_01Y2RYXXXWmANdfeSAyyzmUa
</commit_message>
<xml_diff>
--- a/Ocean Crest Pier Monthly Report — September 2026.pptx
+++ b/Ocean Crest Pier Monthly Report — September 2026.pptx
@@ -841,7 +841,7 @@
                   <c:v>0</c:v>
                 </c:pt>
                 <c:pt idx="3">
-                  <c:v>32241</c:v>
+                  <c:v>10380</c:v>
                 </c:pt>
                 <c:pt idx="4">
                   <c:v>0</c:v>
@@ -5440,7 +5440,7 @@
                 </a:solidFill>
                 <a:latin typeface="Jost"/>
               </a:rPr>
-              <a:t>Restore Facebook posting cadence — down 22% this period (25 vs. 32 posts). Aim for 32+ posts next period.</a:t>
+              <a:t>Restore Facebook posting cadence — down 31% this period (22 vs. 32 posts). Aim for 32+ posts next period.</a:t>
             </a:r>
           </a:p>
           <a:p>
@@ -5458,7 +5458,7 @@
                 </a:solidFill>
                 <a:latin typeface="Jost"/>
               </a:rPr>
-              <a:t>Close the engagement gap on Facebook — trailing TikTok by 6.7 points (0.74% vs. 7.40%). Borrow whatever content approach is working on TikTok.</a:t>
+              <a:t>Close the engagement gap on Facebook — trailing TikTok by 6.0 points (1.37% vs. 7.40%). Borrow whatever content approach is working on TikTok.</a:t>
             </a:r>
           </a:p>
         </p:txBody>
@@ -8012,7 +8012,7 @@
                 </a:solidFill>
                 <a:latin typeface="Jost"/>
               </a:rPr>
-              <a:t>47.8K</a:t>
+              <a:t>26.0K</a:t>
             </a:r>
           </a:p>
           <a:p>
@@ -8024,7 +8024,7 @@
                 </a:solidFill>
                 <a:latin typeface="Jost"/>
               </a:rPr>
-              <a:t>↓ -20.5%</a:t>
+              <a:t>↓ -56.9%</a:t>
             </a:r>
           </a:p>
         </p:txBody>
@@ -8093,7 +8093,7 @@
                 </a:solidFill>
                 <a:latin typeface="Jost"/>
               </a:rPr>
-              <a:t>0.74%</a:t>
+              <a:t>1.37%</a:t>
             </a:r>
           </a:p>
           <a:p>
@@ -8101,11 +8101,11 @@
             <a:r>
               <a:rPr sz="900" b="1">
                 <a:solidFill>
-                  <a:srgbClr val="7A7889"/>
+                  <a:srgbClr val="2D55C9"/>
                 </a:solidFill>
                 <a:latin typeface="Jost"/>
               </a:rPr>
-              <a:t>↓ -42.1%</a:t>
+              <a:t>↑ +6.6%</a:t>
             </a:r>
           </a:p>
         </p:txBody>
@@ -8352,7 +8352,7 @@
                         </a:defRPr>
                       </a:pPr>
                       <a:r>
-                        <a:t>25</a:t>
+                        <a:t>22</a:t>
                       </a:r>
                     </a:p>
                   </a:txBody>
@@ -8400,7 +8400,7 @@
                         </a:defRPr>
                       </a:pPr>
                       <a:r>
-                        <a:t>↓ -21.9%</a:t>
+                        <a:t>↓ -31.2%</a:t>
                       </a:r>
                     </a:p>
                   </a:txBody>
@@ -8450,7 +8450,7 @@
                         </a:defRPr>
                       </a:pPr>
                       <a:r>
-                        <a:t>47.8K</a:t>
+                        <a:t>26.0K</a:t>
                       </a:r>
                     </a:p>
                   </a:txBody>
@@ -8498,7 +8498,7 @@
                         </a:defRPr>
                       </a:pPr>
                       <a:r>
-                        <a:t>↓ -20.5%</a:t>
+                        <a:t>↓ -56.9%</a:t>
                       </a:r>
                     </a:p>
                   </a:txBody>
@@ -8842,7 +8842,7 @@
                         </a:defRPr>
                       </a:pPr>
                       <a:r>
-                        <a:t>3.2K</a:t>
+                        <a:t>1.4K</a:t>
                       </a:r>
                     </a:p>
                   </a:txBody>
@@ -8884,13 +8884,13 @@
                       <a:pPr>
                         <a:defRPr sz="800">
                           <a:solidFill>
-                            <a:srgbClr val="2D55C9"/>
-                          </a:solidFill>
-                          <a:latin typeface="Jost"/>
-                        </a:defRPr>
-                      </a:pPr>
-                      <a:r>
-                        <a:t>↑ +4.3%</a:t>
+                            <a:srgbClr val="7A7889"/>
+                          </a:solidFill>
+                          <a:latin typeface="Jost"/>
+                        </a:defRPr>
+                      </a:pPr>
+                      <a:r>
+                        <a:t>↓ -53.3%</a:t>
                       </a:r>
                     </a:p>
                   </a:txBody>
@@ -8940,7 +8940,7 @@
                         </a:defRPr>
                       </a:pPr>
                       <a:r>
-                        <a:t>0.74%</a:t>
+                        <a:t>1.37%</a:t>
                       </a:r>
                     </a:p>
                   </a:txBody>
@@ -8982,13 +8982,13 @@
                       <a:pPr>
                         <a:defRPr sz="800">
                           <a:solidFill>
-                            <a:srgbClr val="7A7889"/>
-                          </a:solidFill>
-                          <a:latin typeface="Jost"/>
-                        </a:defRPr>
-                      </a:pPr>
-                      <a:r>
-                        <a:t>↓ -42.1%</a:t>
+                            <a:srgbClr val="2D55C9"/>
+                          </a:solidFill>
+                          <a:latin typeface="Jost"/>
+                        </a:defRPr>
+                      </a:pPr>
+                      <a:r>
+                        <a:t>↑ +6.6%</a:t>
                       </a:r>
                     </a:p>
                   </a:txBody>
@@ -9032,7 +9032,7 @@
                 </a:solidFill>
                 <a:latin typeface="Jost"/>
               </a:rPr>
-              <a:t>Most metrics are down this period alongside a 22% drop in posting frequency (25 vs. 32 posts).</a:t>
+              <a:t>Most metrics are down this period alongside a 31% drop in posting frequency (22 vs. 32 posts).</a:t>
             </a:r>
           </a:p>
         </p:txBody>
@@ -9223,7 +9223,7 @@
                 </a:solidFill>
                 <a:latin typeface="Jost"/>
               </a:rPr>
-              <a:t>19%</a:t>
+              <a:t>36%</a:t>
             </a:r>
             <a:r>
               <a:rPr sz="1400" b="0">
@@ -9570,7 +9570,7 @@
                         </a:defRPr>
                       </a:pPr>
                       <a:r>
-                        <a:t>6a9c884c05a53984421ec06f</a:t>
+                        <a:t>Summer on the pier, gone as fast as it came. As we head into Labor Day Weekend, we're so thankful for everyone who made memories with us this season, from sunrise casts and full d…</a:t>
                       </a:r>
                     </a:p>
                   </a:txBody>
@@ -9642,7 +9642,7 @@
                         </a:defRPr>
                       </a:pPr>
                       <a:r>
-                        <a:t>5</a:t>
+                        <a:t>135</a:t>
                       </a:r>
                     </a:p>
                   </a:txBody>
@@ -9666,7 +9666,7 @@
                         </a:defRPr>
                       </a:pPr>
                       <a:r>
-                        <a:t>1</a:t>
+                        <a:t>14</a:t>
                       </a:r>
                     </a:p>
                   </a:txBody>
@@ -9690,7 +9690,7 @@
                         </a:defRPr>
                       </a:pPr>
                       <a:r>
-                        <a:t>0</a:t>
+                        <a:t>2</a:t>
                       </a:r>
                     </a:p>
                   </a:txBody>
@@ -9716,7 +9716,7 @@
                         </a:defRPr>
                       </a:pPr>
                       <a:r>
-                        <a:t>6a9b144b5397054087a46af8</a:t>
+                        <a:t>Photo post (no caption)</a:t>
                       </a:r>
                     </a:p>
                   </a:txBody>
@@ -9764,7 +9764,7 @@
                         </a:defRPr>
                       </a:pPr>
                       <a:r>
-                        <a:t>7.3K</a:t>
+                        <a:t>3.1K</a:t>
                       </a:r>
                     </a:p>
                   </a:txBody>
@@ -9788,7 +9788,7 @@
                         </a:defRPr>
                       </a:pPr>
                       <a:r>
-                        <a:t>11</a:t>
+                        <a:t>24</a:t>
                       </a:r>
                     </a:p>
                   </a:txBody>
@@ -9812,7 +9812,7 @@
                         </a:defRPr>
                       </a:pPr>
                       <a:r>
-                        <a:t>1</a:t>
+                        <a:t>0</a:t>
                       </a:r>
                     </a:p>
                   </a:txBody>
@@ -9836,7 +9836,7 @@
                         </a:defRPr>
                       </a:pPr>
                       <a:r>
-                        <a:t>0</a:t>
+                        <a:t>3</a:t>
                       </a:r>
                     </a:p>
                   </a:txBody>
@@ -9862,7 +9862,7 @@
                         </a:defRPr>
                       </a:pPr>
                       <a:r>
-                        <a:t>6a9ad379f448c5c77eb6dbc5</a:t>
+                        <a:t>Photo post (no caption)</a:t>
                       </a:r>
                     </a:p>
                   </a:txBody>
@@ -9886,7 +9886,7 @@
                         </a:defRPr>
                       </a:pPr>
                       <a:r>
-                        <a:t>Sep 04</a:t>
+                        <a:t>Sep 01</a:t>
                       </a:r>
                     </a:p>
                   </a:txBody>
@@ -9910,7 +9910,7 @@
                         </a:defRPr>
                       </a:pPr>
                       <a:r>
-                        <a:t>7.3K</a:t>
+                        <a:t>2.5K</a:t>
                       </a:r>
                     </a:p>
                   </a:txBody>
@@ -9934,7 +9934,7 @@
                         </a:defRPr>
                       </a:pPr>
                       <a:r>
-                        <a:t>7</a:t>
+                        <a:t>34</a:t>
                       </a:r>
                     </a:p>
                   </a:txBody>
@@ -9958,7 +9958,7 @@
                         </a:defRPr>
                       </a:pPr>
                       <a:r>
-                        <a:t>1</a:t>
+                        <a:t>6</a:t>
                       </a:r>
                     </a:p>
                   </a:txBody>
@@ -10008,7 +10008,7 @@
                         </a:defRPr>
                       </a:pPr>
                       <a:r>
-                        <a:t>Summer on the pier, gone as fast as it came. As we head into Labor Day Weekend, we're so thankful for everyone who made memories with us this season, from sunrise casts and full d…</a:t>
+                        <a:t>This Tiki Bar Lime Lager from Tarboro Brewing is REALLY tasty! Our friends on the beach liked it, you probably will too. Grab one at The Seahorse #SeahorseBar #TarboroBrewing #Oak…</a:t>
                       </a:r>
                     </a:p>
                   </a:txBody>
@@ -10032,7 +10032,7 @@
                         </a:defRPr>
                       </a:pPr>
                       <a:r>
-                        <a:t>Sep 04</a:t>
+                        <a:t>Sep 02</a:t>
                       </a:r>
                     </a:p>
                   </a:txBody>
@@ -10056,7 +10056,7 @@
                         </a:defRPr>
                       </a:pPr>
                       <a:r>
-                        <a:t>7.3K</a:t>
+                        <a:t>2.1K</a:t>
                       </a:r>
                     </a:p>
                   </a:txBody>
@@ -10080,7 +10080,7 @@
                         </a:defRPr>
                       </a:pPr>
                       <a:r>
-                        <a:t>112</a:t>
+                        <a:t>22</a:t>
                       </a:r>
                     </a:p>
                   </a:txBody>
@@ -10104,7 +10104,7 @@
                         </a:defRPr>
                       </a:pPr>
                       <a:r>
-                        <a:t>11</a:t>
+                        <a:t>2</a:t>
                       </a:r>
                     </a:p>
                   </a:txBody>
@@ -10128,7 +10128,7 @@
                         </a:defRPr>
                       </a:pPr>
                       <a:r>
-                        <a:t>2</a:t>
+                        <a:t>8</a:t>
                       </a:r>
                     </a:p>
                   </a:txBody>

</xml_diff>

<commit_message>
Add generated report: Ocean Crest Pier Monthly Report — September 2026.pptx
Co-Authored-By: Claude Sonnet 5.5 <noreply@anthropic.com>
Claude-Session: https://claude.ai/code/session_01FWPtNvXmGhDDnQDaSR7Cg4
</commit_message>
<xml_diff>
--- a/Ocean Crest Pier Monthly Report — September 2026.pptx
+++ b/Ocean Crest Pier Monthly Report — September 2026.pptx
@@ -258,13 +258,13 @@
                   <c:v>0</c:v>
                 </c:pt>
                 <c:pt idx="1">
-                  <c:v>428</c:v>
+                  <c:v>442</c:v>
                 </c:pt>
                 <c:pt idx="2">
                   <c:v>65</c:v>
                 </c:pt>
                 <c:pt idx="3">
-                  <c:v>1201</c:v>
+                  <c:v>1207</c:v>
                 </c:pt>
                 <c:pt idx="4">
                   <c:v>0</c:v>
@@ -273,13 +273,13 @@
                   <c:v>0</c:v>
                 </c:pt>
                 <c:pt idx="6">
-                  <c:v>360</c:v>
+                  <c:v>363</c:v>
                 </c:pt>
                 <c:pt idx="7">
                   <c:v>0</c:v>
                 </c:pt>
                 <c:pt idx="8">
-                  <c:v>760</c:v>
+                  <c:v>763</c:v>
                 </c:pt>
                 <c:pt idx="9">
                   <c:v>0</c:v>
@@ -288,7 +288,7 @@
                   <c:v>0</c:v>
                 </c:pt>
                 <c:pt idx="11">
-                  <c:v>202</c:v>
+                  <c:v>207</c:v>
                 </c:pt>
                 <c:pt idx="12">
                   <c:v>0</c:v>
@@ -300,13 +300,13 @@
                   <c:v>0</c:v>
                 </c:pt>
                 <c:pt idx="15">
-                  <c:v>2053</c:v>
+                  <c:v>2087</c:v>
                 </c:pt>
                 <c:pt idx="16">
                   <c:v>0</c:v>
                 </c:pt>
                 <c:pt idx="17">
-                  <c:v>588</c:v>
+                  <c:v>617</c:v>
                 </c:pt>
                 <c:pt idx="18">
                   <c:v>0</c:v>
@@ -324,7 +324,7 @@
                   <c:v>63</c:v>
                 </c:pt>
                 <c:pt idx="23">
-                  <c:v>240</c:v>
+                  <c:v>268</c:v>
                 </c:pt>
                 <c:pt idx="24">
                   <c:v>0</c:v>
@@ -342,7 +342,7 @@
                   <c:v>0</c:v>
                 </c:pt>
                 <c:pt idx="29">
-                  <c:v>6</c:v>
+                  <c:v>260</c:v>
                 </c:pt>
               </c:numCache>
             </c:numRef>
@@ -487,7 +487,7 @@
                   <c:v>0</c:v>
                 </c:pt>
                 <c:pt idx="3">
-                  <c:v>504</c:v>
+                  <c:v>506</c:v>
                 </c:pt>
                 <c:pt idx="4">
                   <c:v>178</c:v>
@@ -517,7 +517,7 @@
                   <c:v>223</c:v>
                 </c:pt>
                 <c:pt idx="13">
-                  <c:v>360</c:v>
+                  <c:v>364</c:v>
                 </c:pt>
                 <c:pt idx="14">
                   <c:v>117</c:v>
@@ -529,31 +529,31 @@
                   <c:v>77</c:v>
                 </c:pt>
                 <c:pt idx="17">
-                  <c:v>270</c:v>
+                  <c:v>273</c:v>
                 </c:pt>
                 <c:pt idx="18">
                   <c:v>71</c:v>
                 </c:pt>
                 <c:pt idx="19">
-                  <c:v>236</c:v>
+                  <c:v>243</c:v>
                 </c:pt>
                 <c:pt idx="20">
                   <c:v>0</c:v>
                 </c:pt>
                 <c:pt idx="21">
-                  <c:v>422</c:v>
+                  <c:v>425</c:v>
                 </c:pt>
                 <c:pt idx="22">
                   <c:v>0</c:v>
                 </c:pt>
                 <c:pt idx="23">
-                  <c:v>720</c:v>
+                  <c:v>732</c:v>
                 </c:pt>
                 <c:pt idx="24">
                   <c:v>0</c:v>
                 </c:pt>
                 <c:pt idx="25">
-                  <c:v>550</c:v>
+                  <c:v>557</c:v>
                 </c:pt>
                 <c:pt idx="26">
                   <c:v>0</c:v>
@@ -898,10 +898,10 @@
                   <c:v>0</c:v>
                 </c:pt>
                 <c:pt idx="22">
-                  <c:v>0</c:v>
+                  <c:v>8456</c:v>
                 </c:pt>
                 <c:pt idx="23">
-                  <c:v>0</c:v>
+                  <c:v>5707</c:v>
                 </c:pt>
                 <c:pt idx="24">
                   <c:v>0</c:v>
@@ -919,7 +919,7 @@
                   <c:v>0</c:v>
                 </c:pt>
                 <c:pt idx="29">
-                  <c:v>0</c:v>
+                  <c:v>4078</c:v>
                 </c:pt>
               </c:numCache>
             </c:numRef>
@@ -1412,7 +1412,7 @@
                   <c:v>0</c:v>
                 </c:pt>
                 <c:pt idx="1">
-                  <c:v>544</c:v>
+                  <c:v>594</c:v>
                 </c:pt>
                 <c:pt idx="2">
                   <c:v>0</c:v>
@@ -1454,7 +1454,7 @@
                   <c:v>0</c:v>
                 </c:pt>
                 <c:pt idx="15">
-                  <c:v>3913</c:v>
+                  <c:v>5050</c:v>
                 </c:pt>
                 <c:pt idx="16">
                   <c:v>0</c:v>
@@ -1475,7 +1475,7 @@
                   <c:v>0</c:v>
                 </c:pt>
                 <c:pt idx="22">
-                  <c:v>491</c:v>
+                  <c:v>593</c:v>
                 </c:pt>
                 <c:pt idx="23">
                   <c:v>0</c:v>
@@ -1496,7 +1496,7 @@
                   <c:v>0</c:v>
                 </c:pt>
                 <c:pt idx="29">
-                  <c:v>298</c:v>
+                  <c:v>613</c:v>
                 </c:pt>
               </c:numCache>
             </c:numRef>
@@ -1671,7 +1671,7 @@
                   <c:v>0</c:v>
                 </c:pt>
                 <c:pt idx="13">
-                  <c:v>352</c:v>
+                  <c:v>389</c:v>
                 </c:pt>
                 <c:pt idx="14">
                   <c:v>0</c:v>
@@ -1683,31 +1683,31 @@
                   <c:v>0</c:v>
                 </c:pt>
                 <c:pt idx="17">
-                  <c:v>604</c:v>
+                  <c:v>637</c:v>
                 </c:pt>
                 <c:pt idx="18">
                   <c:v>0</c:v>
                 </c:pt>
                 <c:pt idx="19">
-                  <c:v>335</c:v>
+                  <c:v>366</c:v>
                 </c:pt>
                 <c:pt idx="20">
                   <c:v>0</c:v>
                 </c:pt>
                 <c:pt idx="21">
-                  <c:v>742</c:v>
+                  <c:v>780</c:v>
                 </c:pt>
                 <c:pt idx="22">
                   <c:v>0</c:v>
                 </c:pt>
                 <c:pt idx="23">
-                  <c:v>698</c:v>
+                  <c:v>743</c:v>
                 </c:pt>
                 <c:pt idx="24">
                   <c:v>0</c:v>
                 </c:pt>
                 <c:pt idx="25">
-                  <c:v>825</c:v>
+                  <c:v>885</c:v>
                 </c:pt>
                 <c:pt idx="26">
                   <c:v>0</c:v>
@@ -5179,7 +5179,7 @@
                 </a:solidFill>
                 <a:latin typeface="Jost"/>
               </a:rPr>
-              <a:t>[Add goal - mark ✅ if complete]</a:t>
+              <a:t>Restore Instagram posting cadence — down 37% this period (17 vs. 27 posts). Aim for 27+ posts next period.</a:t>
             </a:r>
           </a:p>
           <a:p>
@@ -5197,7 +5197,7 @@
                 </a:solidFill>
                 <a:latin typeface="Jost"/>
               </a:rPr>
-              <a:t>[Add goal - mark ✅ if complete]</a:t>
+              <a:t>Restore TikTok posting cadence — down 33% this period (4 vs. 6 posts). Aim for 6+ posts next period.</a:t>
             </a:r>
           </a:p>
           <a:p>
@@ -5215,7 +5215,7 @@
                 </a:solidFill>
                 <a:latin typeface="Jost"/>
               </a:rPr>
-              <a:t>[Add goal - mark ✅ if complete]</a:t>
+              <a:t>Restore Facebook posting cadence — down 31% this period (22 vs. 32 posts). Aim for 32+ posts next period.</a:t>
             </a:r>
           </a:p>
           <a:p>
@@ -5233,7 +5233,7 @@
                 </a:solidFill>
                 <a:latin typeface="Jost"/>
               </a:rPr>
-              <a:t>[Add goal - mark ✅ if complete]</a:t>
+              <a:t>Close the engagement gap on Facebook — trailing TikTok by 6.0 points (1.37% vs. 7.40%). Borrow whatever content approach is working on TikTok.</a:t>
             </a:r>
           </a:p>
         </p:txBody>
@@ -5458,7 +5458,7 @@
                 </a:solidFill>
                 <a:latin typeface="Jost"/>
               </a:rPr>
-              <a:t>Close the engagement gap on Facebook — trailing TikTok by 6.0 points (1.37% vs. 7.40%). Borrow whatever content approach is working on TikTok.</a:t>
+              <a:t>Close the engagement gap on Facebook — trailing Instagram by 5.7 points (1.28% vs. 6.93%). Borrow whatever content approach is working on Instagram.</a:t>
             </a:r>
           </a:p>
         </p:txBody>
@@ -5657,7 +5657,7 @@
                 </a:solidFill>
                 <a:latin typeface="Jost"/>
               </a:rPr>
-              <a:t>6.2K</a:t>
+              <a:t>6.5K</a:t>
             </a:r>
           </a:p>
           <a:p>
@@ -5669,7 +5669,7 @@
                 </a:solidFill>
                 <a:latin typeface="Jost"/>
               </a:rPr>
-              <a:t>↑ +38.7%</a:t>
+              <a:t>↑ +45.9%</a:t>
             </a:r>
           </a:p>
         </p:txBody>
@@ -5738,7 +5738,7 @@
                 </a:solidFill>
                 <a:latin typeface="Jost"/>
               </a:rPr>
-              <a:t>3.8K</a:t>
+              <a:t>4.0K</a:t>
             </a:r>
           </a:p>
           <a:p>
@@ -5750,7 +5750,7 @@
                 </a:solidFill>
                 <a:latin typeface="Jost"/>
               </a:rPr>
-              <a:t>↑ +24.2%</a:t>
+              <a:t>↑ +31.3%</a:t>
             </a:r>
           </a:p>
         </p:txBody>
@@ -5819,7 +5819,7 @@
                 </a:solidFill>
                 <a:latin typeface="Jost"/>
               </a:rPr>
-              <a:t>6.85%</a:t>
+              <a:t>6.93%</a:t>
             </a:r>
           </a:p>
           <a:p>
@@ -5831,7 +5831,7 @@
                 </a:solidFill>
                 <a:latin typeface="Jost"/>
               </a:rPr>
-              <a:t>↑ +56.8%</a:t>
+              <a:t>↑ +54.5%</a:t>
             </a:r>
           </a:p>
         </p:txBody>
@@ -6095,7 +6095,7 @@
                         </a:defRPr>
                       </a:pPr>
                       <a:r>
-                        <a:t>6.2K</a:t>
+                        <a:t>6.5K</a:t>
                       </a:r>
                     </a:p>
                   </a:txBody>
@@ -6119,7 +6119,7 @@
                         </a:defRPr>
                       </a:pPr>
                       <a:r>
-                        <a:t>4.4K</a:t>
+                        <a:t>4.5K</a:t>
                       </a:r>
                     </a:p>
                   </a:txBody>
@@ -6143,7 +6143,7 @@
                         </a:defRPr>
                       </a:pPr>
                       <a:r>
-                        <a:t>↑ +38.7%</a:t>
+                        <a:t>↑ +45.9%</a:t>
                       </a:r>
                     </a:p>
                   </a:txBody>
@@ -6193,7 +6193,7 @@
                         </a:defRPr>
                       </a:pPr>
                       <a:r>
-                        <a:t>3.8K</a:t>
+                        <a:t>4.0K</a:t>
                       </a:r>
                     </a:p>
                   </a:txBody>
@@ -6217,7 +6217,7 @@
                         </a:defRPr>
                       </a:pPr>
                       <a:r>
-                        <a:t>3.0K</a:t>
+                        <a:t>3.1K</a:t>
                       </a:r>
                     </a:p>
                   </a:txBody>
@@ -6241,7 +6241,7 @@
                         </a:defRPr>
                       </a:pPr>
                       <a:r>
-                        <a:t>↑ +24.2%</a:t>
+                        <a:t>↑ +31.3%</a:t>
                       </a:r>
                     </a:p>
                   </a:txBody>
@@ -6291,7 +6291,7 @@
                         </a:defRPr>
                       </a:pPr>
                       <a:r>
-                        <a:t>203</a:t>
+                        <a:t>223</a:t>
                       </a:r>
                     </a:p>
                   </a:txBody>
@@ -6315,7 +6315,7 @@
                         </a:defRPr>
                       </a:pPr>
                       <a:r>
-                        <a:t>109</a:t>
+                        <a:t>114</a:t>
                       </a:r>
                     </a:p>
                   </a:txBody>
@@ -6339,7 +6339,7 @@
                         </a:defRPr>
                       </a:pPr>
                       <a:r>
-                        <a:t>↑ +86.2%</a:t>
+                        <a:t>↑ +95.6%</a:t>
                       </a:r>
                     </a:p>
                   </a:txBody>
@@ -6389,7 +6389,7 @@
                         </a:defRPr>
                       </a:pPr>
                       <a:r>
-                        <a:t>21</a:t>
+                        <a:t>22</a:t>
                       </a:r>
                     </a:p>
                   </a:txBody>
@@ -6437,7 +6437,7 @@
                         </a:defRPr>
                       </a:pPr>
                       <a:r>
-                        <a:t>↑ +110.0%</a:t>
+                        <a:t>↑ +120.0%</a:t>
                       </a:r>
                     </a:p>
                   </a:txBody>
@@ -6683,7 +6683,7 @@
                         </a:defRPr>
                       </a:pPr>
                       <a:r>
-                        <a:t>6.85%</a:t>
+                        <a:t>6.93%</a:t>
                       </a:r>
                     </a:p>
                   </a:txBody>
@@ -6707,7 +6707,7 @@
                         </a:defRPr>
                       </a:pPr>
                       <a:r>
-                        <a:t>4.37%</a:t>
+                        <a:t>4.49%</a:t>
                       </a:r>
                     </a:p>
                   </a:txBody>
@@ -6731,7 +6731,7 @@
                         </a:defRPr>
                       </a:pPr>
                       <a:r>
-                        <a:t>↑ +56.8%</a:t>
+                        <a:t>↑ +54.5%</a:t>
                       </a:r>
                     </a:p>
                   </a:txBody>
@@ -6932,7 +6932,7 @@
                 </a:solidFill>
                 <a:latin typeface="Jost"/>
               </a:rPr>
-              <a:t>30%</a:t>
+              <a:t>29%</a:t>
             </a:r>
             <a:r>
               <a:rPr sz="1400" b="0">
@@ -7205,7 +7205,7 @@
                         </a:defRPr>
                       </a:pPr>
                       <a:r>
-                        <a:t>68</a:t>
+                        <a:t>69</a:t>
                       </a:r>
                     </a:p>
                   </a:txBody>
@@ -7473,7 +7473,7 @@
                         </a:defRPr>
                       </a:pPr>
                       <a:r>
-                        <a:t>710</a:t>
+                        <a:t>713</a:t>
                       </a:r>
                     </a:p>
                   </a:txBody>
@@ -7619,7 +7619,7 @@
                         </a:defRPr>
                       </a:pPr>
                       <a:r>
-                        <a:t>588</a:t>
+                        <a:t>617</a:t>
                       </a:r>
                     </a:p>
                   </a:txBody>
@@ -7643,7 +7643,7 @@
                         </a:defRPr>
                       </a:pPr>
                       <a:r>
-                        <a:t>11</a:t>
+                        <a:t>13</a:t>
                       </a:r>
                     </a:p>
                   </a:txBody>
@@ -7765,7 +7765,7 @@
                         </a:defRPr>
                       </a:pPr>
                       <a:r>
-                        <a:t>428</a:t>
+                        <a:t>442</a:t>
                       </a:r>
                     </a:p>
                   </a:txBody>
@@ -7789,7 +7789,7 @@
                         </a:defRPr>
                       </a:pPr>
                       <a:r>
-                        <a:t>16</a:t>
+                        <a:t>17</a:t>
                       </a:r>
                     </a:p>
                   </a:txBody>
@@ -8012,7 +8012,7 @@
                 </a:solidFill>
                 <a:latin typeface="Jost"/>
               </a:rPr>
-              <a:t>26.0K</a:t>
+              <a:t>44.2K</a:t>
             </a:r>
           </a:p>
           <a:p>
@@ -8024,7 +8024,7 @@
                 </a:solidFill>
                 <a:latin typeface="Jost"/>
               </a:rPr>
-              <a:t>↓ -56.9%</a:t>
+              <a:t>↓ -26.6%</a:t>
             </a:r>
           </a:p>
         </p:txBody>
@@ -8093,7 +8093,7 @@
                 </a:solidFill>
                 <a:latin typeface="Jost"/>
               </a:rPr>
-              <a:t>1.37%</a:t>
+              <a:t>1.28%</a:t>
             </a:r>
           </a:p>
           <a:p>
@@ -8101,11 +8101,11 @@
             <a:r>
               <a:rPr sz="900" b="1">
                 <a:solidFill>
-                  <a:srgbClr val="2D55C9"/>
+                  <a:srgbClr val="7A7889"/>
                 </a:solidFill>
                 <a:latin typeface="Jost"/>
               </a:rPr>
-              <a:t>↑ +6.6%</a:t>
+              <a:t>↓ -0.2%</a:t>
             </a:r>
           </a:p>
         </p:txBody>
@@ -8174,7 +8174,7 @@
                 </a:solidFill>
                 <a:latin typeface="Jost"/>
               </a:rPr>
-              <a:t>18.3K</a:t>
+              <a:t>18.4K</a:t>
             </a:r>
           </a:p>
           <a:p>
@@ -8182,11 +8182,11 @@
             <a:r>
               <a:rPr sz="900" b="1">
                 <a:solidFill>
-                  <a:srgbClr val="3A3845"/>
+                  <a:srgbClr val="2D55C9"/>
                 </a:solidFill>
                 <a:latin typeface="Jost"/>
               </a:rPr>
-              <a:t>First snapshot</a:t>
+              <a:t>↑ +0.6%</a:t>
             </a:r>
           </a:p>
         </p:txBody>
@@ -8450,7 +8450,7 @@
                         </a:defRPr>
                       </a:pPr>
                       <a:r>
-                        <a:t>26.0K</a:t>
+                        <a:t>44.2K</a:t>
                       </a:r>
                     </a:p>
                   </a:txBody>
@@ -8498,7 +8498,7 @@
                         </a:defRPr>
                       </a:pPr>
                       <a:r>
-                        <a:t>↓ -56.9%</a:t>
+                        <a:t>↓ -26.6%</a:t>
                       </a:r>
                     </a:p>
                   </a:txBody>
@@ -8548,7 +8548,7 @@
                         </a:defRPr>
                       </a:pPr>
                       <a:r>
-                        <a:t>313</a:t>
+                        <a:t>514</a:t>
                       </a:r>
                     </a:p>
                   </a:txBody>
@@ -8596,7 +8596,7 @@
                         </a:defRPr>
                       </a:pPr>
                       <a:r>
-                        <a:t>↓ -52.6%</a:t>
+                        <a:t>↓ -22.1%</a:t>
                       </a:r>
                     </a:p>
                   </a:txBody>
@@ -8646,7 +8646,7 @@
                         </a:defRPr>
                       </a:pPr>
                       <a:r>
-                        <a:t>23</a:t>
+                        <a:t>27</a:t>
                       </a:r>
                     </a:p>
                   </a:txBody>
@@ -8694,7 +8694,7 @@
                         </a:defRPr>
                       </a:pPr>
                       <a:r>
-                        <a:t>↓ -72.3%</a:t>
+                        <a:t>↓ -67.5%</a:t>
                       </a:r>
                     </a:p>
                   </a:txBody>
@@ -8744,7 +8744,7 @@
                         </a:defRPr>
                       </a:pPr>
                       <a:r>
-                        <a:t>19</a:t>
+                        <a:t>25</a:t>
                       </a:r>
                     </a:p>
                   </a:txBody>
@@ -8792,7 +8792,7 @@
                         </a:defRPr>
                       </a:pPr>
                       <a:r>
-                        <a:t>↓ -34.5%</a:t>
+                        <a:t>↓ -13.8%</a:t>
                       </a:r>
                     </a:p>
                   </a:txBody>
@@ -8842,7 +8842,7 @@
                         </a:defRPr>
                       </a:pPr>
                       <a:r>
-                        <a:t>1.4K</a:t>
+                        <a:t>1.9K</a:t>
                       </a:r>
                     </a:p>
                   </a:txBody>
@@ -8890,7 +8890,7 @@
                         </a:defRPr>
                       </a:pPr>
                       <a:r>
-                        <a:t>↓ -53.3%</a:t>
+                        <a:t>↓ -36.6%</a:t>
                       </a:r>
                     </a:p>
                   </a:txBody>
@@ -8940,7 +8940,7 @@
                         </a:defRPr>
                       </a:pPr>
                       <a:r>
-                        <a:t>1.37%</a:t>
+                        <a:t>1.28%</a:t>
                       </a:r>
                     </a:p>
                   </a:txBody>
@@ -8982,13 +8982,13 @@
                       <a:pPr>
                         <a:defRPr sz="800">
                           <a:solidFill>
-                            <a:srgbClr val="2D55C9"/>
-                          </a:solidFill>
-                          <a:latin typeface="Jost"/>
-                        </a:defRPr>
-                      </a:pPr>
-                      <a:r>
-                        <a:t>↑ +6.6%</a:t>
+                            <a:srgbClr val="7A7889"/>
+                          </a:solidFill>
+                          <a:latin typeface="Jost"/>
+                        </a:defRPr>
+                      </a:pPr>
+                      <a:r>
+                        <a:t>↓ -0.2%</a:t>
                       </a:r>
                     </a:p>
                   </a:txBody>
@@ -9223,7 +9223,7 @@
                 </a:solidFill>
                 <a:latin typeface="Jost"/>
               </a:rPr>
-              <a:t>36%</a:t>
+              <a:t>21%</a:t>
             </a:r>
             <a:r>
               <a:rPr sz="1400" b="0">
@@ -9570,7 +9570,7 @@
                         </a:defRPr>
                       </a:pPr>
                       <a:r>
-                        <a:t>Summer on the pier, gone as fast as it came. As we head into Labor Day Weekend, we're so thankful for everyone who made memories with us this season, from sunrise casts and full d…</a:t>
+                        <a:t>WE ARE FAMILY! Friends and employees! You never know what will happen here!</a:t>
                       </a:r>
                     </a:p>
                   </a:txBody>
@@ -9594,7 +9594,7 @@
                         </a:defRPr>
                       </a:pPr>
                       <a:r>
-                        <a:t>Sep 04</a:t>
+                        <a:t>Sep 23</a:t>
                       </a:r>
                     </a:p>
                   </a:txBody>
@@ -9618,7 +9618,7 @@
                         </a:defRPr>
                       </a:pPr>
                       <a:r>
-                        <a:t>7.3K</a:t>
+                        <a:t>8.5K</a:t>
                       </a:r>
                     </a:p>
                   </a:txBody>
@@ -9642,7 +9642,7 @@
                         </a:defRPr>
                       </a:pPr>
                       <a:r>
-                        <a:t>135</a:t>
+                        <a:t>61</a:t>
                       </a:r>
                     </a:p>
                   </a:txBody>
@@ -9666,7 +9666,7 @@
                         </a:defRPr>
                       </a:pPr>
                       <a:r>
-                        <a:t>14</a:t>
+                        <a:t>0</a:t>
                       </a:r>
                     </a:p>
                   </a:txBody>
@@ -9690,7 +9690,7 @@
                         </a:defRPr>
                       </a:pPr>
                       <a:r>
-                        <a:t>2</a:t>
+                        <a:t>1</a:t>
                       </a:r>
                     </a:p>
                   </a:txBody>
@@ -9716,7 +9716,7 @@
                         </a:defRPr>
                       </a:pPr>
                       <a:r>
-                        <a:t>Photo post (no caption)</a:t>
+                        <a:t>Summer on the pier, gone as fast as it came. As we head into Labor Day Weekend, we're so thankful for everyone who made memories with us this season, from sunrise casts and full d…</a:t>
                       </a:r>
                     </a:p>
                   </a:txBody>
@@ -9764,7 +9764,7 @@
                         </a:defRPr>
                       </a:pPr>
                       <a:r>
-                        <a:t>3.1K</a:t>
+                        <a:t>7.3K</a:t>
                       </a:r>
                     </a:p>
                   </a:txBody>
@@ -9788,7 +9788,7 @@
                         </a:defRPr>
                       </a:pPr>
                       <a:r>
-                        <a:t>24</a:t>
+                        <a:t>135</a:t>
                       </a:r>
                     </a:p>
                   </a:txBody>
@@ -9812,7 +9812,7 @@
                         </a:defRPr>
                       </a:pPr>
                       <a:r>
-                        <a:t>0</a:t>
+                        <a:t>14</a:t>
                       </a:r>
                     </a:p>
                   </a:txBody>
@@ -9836,7 +9836,7 @@
                         </a:defRPr>
                       </a:pPr>
                       <a:r>
-                        <a:t>3</a:t>
+                        <a:t>2</a:t>
                       </a:r>
                     </a:p>
                   </a:txBody>
@@ -9862,7 +9862,7 @@
                         </a:defRPr>
                       </a:pPr>
                       <a:r>
-                        <a:t>Photo post (no caption)</a:t>
+                        <a:t>Some nights you don't need a plan. Just a seat under the deck at the Seahorse, a sliver of moon over the dunes, and the sound of the waves doing what they've always done. The red…</a:t>
                       </a:r>
                     </a:p>
                   </a:txBody>
@@ -9886,7 +9886,7 @@
                         </a:defRPr>
                       </a:pPr>
                       <a:r>
-                        <a:t>Sep 01</a:t>
+                        <a:t>Sep 24</a:t>
                       </a:r>
                     </a:p>
                   </a:txBody>
@@ -9910,7 +9910,7 @@
                         </a:defRPr>
                       </a:pPr>
                       <a:r>
-                        <a:t>2.5K</a:t>
+                        <a:t>5.7K</a:t>
                       </a:r>
                     </a:p>
                   </a:txBody>
@@ -9934,7 +9934,7 @@
                         </a:defRPr>
                       </a:pPr>
                       <a:r>
-                        <a:t>34</a:t>
+                        <a:t>100</a:t>
                       </a:r>
                     </a:p>
                   </a:txBody>
@@ -9958,7 +9958,7 @@
                         </a:defRPr>
                       </a:pPr>
                       <a:r>
-                        <a:t>6</a:t>
+                        <a:t>2</a:t>
                       </a:r>
                     </a:p>
                   </a:txBody>
@@ -9982,7 +9982,7 @@
                         </a:defRPr>
                       </a:pPr>
                       <a:r>
-                        <a:t>0</a:t>
+                        <a:t>1</a:t>
                       </a:r>
                     </a:p>
                   </a:txBody>
@@ -10008,7 +10008,7 @@
                         </a:defRPr>
                       </a:pPr>
                       <a:r>
-                        <a:t>This Tiki Bar Lime Lager from Tarboro Brewing is REALLY tasty! Our friends on the beach liked it, you probably will too. Grab one at The Seahorse #SeahorseBar #TarboroBrewing #Oak…</a:t>
+                        <a:t>We sat down with King &amp; Co. before their last set, and they said it best: people come to the beach to take a breath and forget about regular life for a while, and they love gettin…</a:t>
                       </a:r>
                     </a:p>
                   </a:txBody>
@@ -10032,7 +10032,7 @@
                         </a:defRPr>
                       </a:pPr>
                       <a:r>
-                        <a:t>Sep 02</a:t>
+                        <a:t>Sep 30</a:t>
                       </a:r>
                     </a:p>
                   </a:txBody>
@@ -10056,7 +10056,7 @@
                         </a:defRPr>
                       </a:pPr>
                       <a:r>
-                        <a:t>2.1K</a:t>
+                        <a:t>4.1K</a:t>
                       </a:r>
                     </a:p>
                   </a:txBody>
@@ -10080,7 +10080,7 @@
                         </a:defRPr>
                       </a:pPr>
                       <a:r>
-                        <a:t>22</a:t>
+                        <a:t>40</a:t>
                       </a:r>
                     </a:p>
                   </a:txBody>
@@ -10128,7 +10128,7 @@
                         </a:defRPr>
                       </a:pPr>
                       <a:r>
-                        <a:t>8</a:t>
+                        <a:t>4</a:t>
                       </a:r>
                     </a:p>
                   </a:txBody>
@@ -10303,7 +10303,7 @@
                 </a:solidFill>
                 <a:latin typeface="Jost"/>
               </a:rPr>
-              <a:t>5.2K</a:t>
+              <a:t>6.8K</a:t>
             </a:r>
           </a:p>
           <a:p>
@@ -10315,7 +10315,7 @@
                 </a:solidFill>
                 <a:latin typeface="Jost"/>
               </a:rPr>
-              <a:t>↑ +47.5%</a:t>
+              <a:t>↑ +80.3%</a:t>
             </a:r>
           </a:p>
         </p:txBody>
@@ -10384,7 +10384,7 @@
                 </a:solidFill>
                 <a:latin typeface="Jost"/>
               </a:rPr>
-              <a:t>3.8K</a:t>
+              <a:t>5.5K</a:t>
             </a:r>
           </a:p>
           <a:p>
@@ -10396,7 +10396,7 @@
                 </a:solidFill>
                 <a:latin typeface="Jost"/>
               </a:rPr>
-              <a:t>↑ +27.8%</a:t>
+              <a:t>↑ +73.4%</a:t>
             </a:r>
           </a:p>
         </p:txBody>
@@ -10465,7 +10465,7 @@
                 </a:solidFill>
                 <a:latin typeface="Jost"/>
               </a:rPr>
-              <a:t>7.40%</a:t>
+              <a:t>6.57%</a:t>
             </a:r>
           </a:p>
           <a:p>
@@ -10477,7 +10477,7 @@
                 </a:solidFill>
                 <a:latin typeface="Jost"/>
               </a:rPr>
-              <a:t>↑ +28.4%</a:t>
+              <a:t>↑ +17.9%</a:t>
             </a:r>
           </a:p>
         </p:txBody>
@@ -10822,7 +10822,7 @@
                         </a:defRPr>
                       </a:pPr>
                       <a:r>
-                        <a:t>5.2K</a:t>
+                        <a:t>6.8K</a:t>
                       </a:r>
                     </a:p>
                   </a:txBody>
@@ -10846,7 +10846,7 @@
                         </a:defRPr>
                       </a:pPr>
                       <a:r>
-                        <a:t>3.6K</a:t>
+                        <a:t>3.8K</a:t>
                       </a:r>
                     </a:p>
                   </a:txBody>
@@ -10870,7 +10870,7 @@
                         </a:defRPr>
                       </a:pPr>
                       <a:r>
-                        <a:t>↑ +47.5%</a:t>
+                        <a:t>↑ +80.3%</a:t>
                       </a:r>
                     </a:p>
                   </a:txBody>
@@ -10920,7 +10920,7 @@
                         </a:defRPr>
                       </a:pPr>
                       <a:r>
-                        <a:t>3.8K</a:t>
+                        <a:t>5.5K</a:t>
                       </a:r>
                     </a:p>
                   </a:txBody>
@@ -10944,7 +10944,7 @@
                         </a:defRPr>
                       </a:pPr>
                       <a:r>
-                        <a:t>3.0K</a:t>
+                        <a:t>3.2K</a:t>
                       </a:r>
                     </a:p>
                   </a:txBody>
@@ -10968,7 +10968,7 @@
                         </a:defRPr>
                       </a:pPr>
                       <a:r>
-                        <a:t>↑ +27.8%</a:t>
+                        <a:t>↑ +73.4%</a:t>
                       </a:r>
                     </a:p>
                   </a:txBody>
@@ -11018,7 +11018,7 @@
                         </a:defRPr>
                       </a:pPr>
                       <a:r>
-                        <a:t>259</a:t>
+                        <a:t>326</a:t>
                       </a:r>
                     </a:p>
                   </a:txBody>
@@ -11042,7 +11042,7 @@
                         </a:defRPr>
                       </a:pPr>
                       <a:r>
-                        <a:t>141</a:t>
+                        <a:t>145</a:t>
                       </a:r>
                     </a:p>
                   </a:txBody>
@@ -11066,7 +11066,7 @@
                         </a:defRPr>
                       </a:pPr>
                       <a:r>
-                        <a:t>↑ +83.7%</a:t>
+                        <a:t>↑ +124.8%</a:t>
                       </a:r>
                     </a:p>
                   </a:txBody>
@@ -11116,7 +11116,7 @@
                         </a:defRPr>
                       </a:pPr>
                       <a:r>
-                        <a:t>8</a:t>
+                        <a:t>15</a:t>
                       </a:r>
                     </a:p>
                   </a:txBody>
@@ -11164,7 +11164,7 @@
                         </a:defRPr>
                       </a:pPr>
                       <a:r>
-                        <a:t>↓ -57.9%</a:t>
+                        <a:t>↓ -21.1%</a:t>
                       </a:r>
                     </a:p>
                   </a:txBody>
@@ -11214,7 +11214,7 @@
                         </a:defRPr>
                       </a:pPr>
                       <a:r>
-                        <a:t>17</a:t>
+                        <a:t>23</a:t>
                       </a:r>
                     </a:p>
                   </a:txBody>
@@ -11238,7 +11238,7 @@
                         </a:defRPr>
                       </a:pPr>
                       <a:r>
-                        <a:t>13</a:t>
+                        <a:t>14</a:t>
                       </a:r>
                     </a:p>
                   </a:txBody>
@@ -11262,7 +11262,7 @@
                         </a:defRPr>
                       </a:pPr>
                       <a:r>
-                        <a:t>↑ +30.8%</a:t>
+                        <a:t>↑ +64.3%</a:t>
                       </a:r>
                     </a:p>
                   </a:txBody>
@@ -11312,7 +11312,7 @@
                         </a:defRPr>
                       </a:pPr>
                       <a:r>
-                        <a:t>7.40%</a:t>
+                        <a:t>6.57%</a:t>
                       </a:r>
                     </a:p>
                   </a:txBody>
@@ -11336,7 +11336,7 @@
                         </a:defRPr>
                       </a:pPr>
                       <a:r>
-                        <a:t>5.76%</a:t>
+                        <a:t>5.57%</a:t>
                       </a:r>
                     </a:p>
                   </a:txBody>
@@ -11360,7 +11360,7 @@
                         </a:defRPr>
                       </a:pPr>
                       <a:r>
-                        <a:t>↑ +28.4%</a:t>
+                        <a:t>↑ +17.9%</a:t>
                       </a:r>
                     </a:p>
                   </a:txBody>
@@ -11595,7 +11595,7 @@
                 </a:solidFill>
                 <a:latin typeface="Jost"/>
               </a:rPr>
-              <a:t>75%</a:t>
+              <a:t>74%</a:t>
             </a:r>
             <a:r>
               <a:rPr sz="1400" b="0">
@@ -11844,7 +11844,7 @@
                         </a:defRPr>
                       </a:pPr>
                       <a:r>
-                        <a:t>3.9K</a:t>
+                        <a:t>5.0K</a:t>
                       </a:r>
                     </a:p>
                   </a:txBody>
@@ -11868,7 +11868,7 @@
                         </a:defRPr>
                       </a:pPr>
                       <a:r>
-                        <a:t>198</a:t>
+                        <a:t>245</a:t>
                       </a:r>
                     </a:p>
                   </a:txBody>
@@ -11892,7 +11892,7 @@
                         </a:defRPr>
                       </a:pPr>
                       <a:r>
-                        <a:t>6</a:t>
+                        <a:t>9</a:t>
                       </a:r>
                     </a:p>
                   </a:txBody>
@@ -11916,7 +11916,7 @@
                         </a:defRPr>
                       </a:pPr>
                       <a:r>
-                        <a:t>17</a:t>
+                        <a:t>21</a:t>
                       </a:r>
                     </a:p>
                   </a:txBody>
@@ -11942,7 +11942,7 @@
                         </a:defRPr>
                       </a:pPr>
                       <a:r>
-                        <a:t>This Tiki Bar Lime Lager from Tarboro Brewing is REALLY tasty! Our friends on the beach liked it, you probably will too. Grab one at The Seahorse #SeahorseBar #TarboroBrewing #Oak…</a:t>
+                        <a:t>POV: your favorite band is a family and they're coming back to the pier 🎶 King &amp; Co. and daughter Harmony return to the Seahorse Bar Sunday, Nov 22. Come dance. #OakIslandNC #Live…</a:t>
                       </a:r>
                     </a:p>
                   </a:txBody>
@@ -11966,7 +11966,7 @@
                         </a:defRPr>
                       </a:pPr>
                       <a:r>
-                        <a:t>Sep 02</a:t>
+                        <a:t>Sep 30</a:t>
                       </a:r>
                     </a:p>
                   </a:txBody>
@@ -11990,7 +11990,7 @@
                         </a:defRPr>
                       </a:pPr>
                       <a:r>
-                        <a:t>544</a:t>
+                        <a:t>613</a:t>
                       </a:r>
                     </a:p>
                   </a:txBody>
@@ -12014,7 +12014,7 @@
                         </a:defRPr>
                       </a:pPr>
                       <a:r>
-                        <a:t>24</a:t>
+                        <a:t>30</a:t>
                       </a:r>
                     </a:p>
                   </a:txBody>
@@ -12038,31 +12038,31 @@
                         </a:defRPr>
                       </a:pPr>
                       <a:r>
+                        <a:t>3</a:t>
+                      </a:r>
+                    </a:p>
+                  </a:txBody>
+                  <a:tcPr marT="25400" marB="25400">
+                    <a:solidFill>
+                      <a:srgbClr val="FFFFFF"/>
+                    </a:solidFill>
+                  </a:tcPr>
+                </a:tc>
+                <a:tc>
+                  <a:txBody>
+                    <a:bodyPr/>
+                    <a:lstStyle/>
+                    <a:p>
+                      <a:pPr>
+                        <a:defRPr sz="900">
+                          <a:solidFill>
+                            <a:srgbClr val="0E0E12"/>
+                          </a:solidFill>
+                          <a:latin typeface="Jost"/>
+                        </a:defRPr>
+                      </a:pPr>
+                      <a:r>
                         <a:t>1</a:t>
-                      </a:r>
-                    </a:p>
-                  </a:txBody>
-                  <a:tcPr marT="25400" marB="25400">
-                    <a:solidFill>
-                      <a:srgbClr val="FFFFFF"/>
-                    </a:solidFill>
-                  </a:tcPr>
-                </a:tc>
-                <a:tc>
-                  <a:txBody>
-                    <a:bodyPr/>
-                    <a:lstStyle/>
-                    <a:p>
-                      <a:pPr>
-                        <a:defRPr sz="900">
-                          <a:solidFill>
-                            <a:srgbClr val="0E0E12"/>
-                          </a:solidFill>
-                          <a:latin typeface="Jost"/>
-                        </a:defRPr>
-                      </a:pPr>
-                      <a:r>
-                        <a:t>0</a:t>
                       </a:r>
                     </a:p>
                   </a:txBody>
@@ -12088,7 +12088,7 @@
                         </a:defRPr>
                       </a:pPr>
                       <a:r>
-                        <a:t>Asked him what he's catching off the pier. He said rays. Solid answer honestly - two rays were caught right after! #OakIslandNC #SeahorseBar #BeachLife #PierLife #NCcoast</a:t>
+                        <a:t>This Tiki Bar Lime Lager from Tarboro Brewing is REALLY tasty! Our friends on the beach liked it, you probably will too. Grab one at The Seahorse #SeahorseBar #TarboroBrewing #Oak…</a:t>
                       </a:r>
                     </a:p>
                   </a:txBody>
@@ -12112,7 +12112,7 @@
                         </a:defRPr>
                       </a:pPr>
                       <a:r>
-                        <a:t>Sep 23</a:t>
+                        <a:t>Sep 02</a:t>
                       </a:r>
                     </a:p>
                   </a:txBody>
@@ -12136,7 +12136,7 @@
                         </a:defRPr>
                       </a:pPr>
                       <a:r>
-                        <a:t>491</a:t>
+                        <a:t>594</a:t>
                       </a:r>
                     </a:p>
                   </a:txBody>
@@ -12160,7 +12160,7 @@
                         </a:defRPr>
                       </a:pPr>
                       <a:r>
-                        <a:t>23</a:t>
+                        <a:t>24</a:t>
                       </a:r>
                     </a:p>
                   </a:txBody>
@@ -12234,7 +12234,7 @@
                         </a:defRPr>
                       </a:pPr>
                       <a:r>
-                        <a:t>POV: your favorite band is a family and they're coming back to the pier 🎶 King &amp; Co. and daughter Harmony return to the Seahorse Bar Sunday, Nov 22. Come dance. #OakIslandNC #Live…</a:t>
+                        <a:t>Asked him what he's catching off the pier. He said rays. Solid answer honestly - two rays were caught right after! #OakIslandNC #SeahorseBar #BeachLife #PierLife #NCcoast</a:t>
                       </a:r>
                     </a:p>
                   </a:txBody>
@@ -12258,7 +12258,7 @@
                         </a:defRPr>
                       </a:pPr>
                       <a:r>
-                        <a:t>Sep 30</a:t>
+                        <a:t>Sep 23</a:t>
                       </a:r>
                     </a:p>
                   </a:txBody>
@@ -12282,7 +12282,7 @@
                         </a:defRPr>
                       </a:pPr>
                       <a:r>
-                        <a:t>298</a:t>
+                        <a:t>593</a:t>
                       </a:r>
                     </a:p>
                   </a:txBody>
@@ -12306,7 +12306,7 @@
                         </a:defRPr>
                       </a:pPr>
                       <a:r>
-                        <a:t>14</a:t>
+                        <a:t>27</a:t>
                       </a:r>
                     </a:p>
                   </a:txBody>
@@ -12330,7 +12330,7 @@
                         </a:defRPr>
                       </a:pPr>
                       <a:r>
-                        <a:t>0</a:t>
+                        <a:t>2</a:t>
                       </a:r>
                     </a:p>
                   </a:txBody>
@@ -12354,7 +12354,7 @@
                         </a:defRPr>
                       </a:pPr>
                       <a:r>
-                        <a:t>0</a:t>
+                        <a:t>1</a:t>
                       </a:r>
                     </a:p>
                   </a:txBody>

</xml_diff>